<commit_message>
Sales pitch STAN : vraies photos dans le diapo
Co-Authored-By: Claude Opus 5.5 <noreply@anthropic.com>
Claude-Session: https://claude.ai/code/session_0139jFUcwaGiy613YY55suuW
</commit_message>
<xml_diff>
--- a/sales-pitch-anglais/Sales pitch - STAN T-rex.pptx
+++ b/sales-pitch-anglais/Sales pitch - STAN T-rex.pptx
@@ -509,13 +509,13 @@
           <a:lstStyle/>
           <a:p>
             <a:r>
-              <a:t>PHOTO À METTRE (clic droit &gt; Changer l'image) : le squelette complet de Stan, de profil, fond noir (recherche : « Stan T-rex Christie's »)</a:t>
+              <a:t>Slide 1 — Introduction</a:t>
             </a:r>
           </a:p>
           <a:p/>
           <a:p>
             <a:r>
-              <a:t>Slide 1 — Introduction</a:t>
+              <a:t>Photo : Stan, National Museum of Nature and Science, Tokyo (Wikimedia Commons)</a:t>
             </a:r>
           </a:p>
         </p:txBody>
@@ -585,13 +585,13 @@
           <a:lstStyle/>
           <a:p>
             <a:r>
-              <a:t>PHOTO À METTRE (clic droit &gt; Changer l'image) : gros plan sur le crâne de Stan</a:t>
+              <a:t>Slide 2 — FEATURE : âge</a:t>
             </a:r>
           </a:p>
           <a:p/>
           <a:p>
             <a:r>
-              <a:t>Slide 2 — FEATURE : âge</a:t>
+              <a:t>Photo : Stan Skull Tyrannosaurus rex (Wikimedia Commons)</a:t>
             </a:r>
           </a:p>
         </p:txBody>
@@ -661,13 +661,13 @@
           <a:lstStyle/>
           <a:p>
             <a:r>
-              <a:t>PHOTO À METTRE (clic droit &gt; Changer l'image) : paysage des Badlands / Hell Creek, Dakota du Sud</a:t>
+              <a:t>Slide 3 — FEATURE : origine</a:t>
             </a:r>
           </a:p>
           <a:p/>
           <a:p>
             <a:r>
-              <a:t>Slide 3 — FEATURE : origine</a:t>
+              <a:t>Photo : Hell Creek State Park (Wikimedia Commons)</a:t>
             </a:r>
           </a:p>
         </p:txBody>
@@ -737,13 +737,13 @@
           <a:lstStyle/>
           <a:p>
             <a:r>
-              <a:t>PHOTO À METTRE (clic droit &gt; Changer l'image) : le squelette entier avec une personne à côté pour l'échelle</a:t>
+              <a:t>Slide 4 — FEATURE : taille</a:t>
             </a:r>
           </a:p>
           <a:p/>
           <a:p>
             <a:r>
-              <a:t>Slide 4 — FEATURE : taille</a:t>
+              <a:t>Photo : T. rex, Smithsonian NMNH, Washington (Wikimedia Commons)</a:t>
             </a:r>
           </a:p>
         </p:txBody>
@@ -813,13 +813,13 @@
           <a:lstStyle/>
           <a:p>
             <a:r>
-              <a:t>PHOTO À METTRE (clic droit &gt; Changer l'image) : photo de fouille / préparation des os en laboratoire</a:t>
+              <a:t>Slide 5 — ADVANTAGE : authentique et complet</a:t>
             </a:r>
           </a:p>
           <a:p/>
           <a:p>
             <a:r>
-              <a:t>Slide 5 — ADVANTAGE : authentique et complet</a:t>
+              <a:t>Photo : Spinophorosaurus digsite (Wikimedia Commons)</a:t>
             </a:r>
           </a:p>
         </p:txBody>
@@ -889,13 +889,13 @@
           <a:lstStyle/>
           <a:p>
             <a:r>
-              <a:t>PHOTO À METTRE (clic droit &gt; Changer l'image) : gros plan sur la mâchoire et les dents</a:t>
+              <a:t>Slide 6 — ADVANTAGE : spectaculaire</a:t>
             </a:r>
           </a:p>
           <a:p/>
           <a:p>
             <a:r>
-              <a:t>Slide 6 — ADVANTAGE : spectaculaire</a:t>
+              <a:t>Photo : T. rex Stan skull (Wikimedia Commons)</a:t>
             </a:r>
           </a:p>
         </p:txBody>
@@ -965,13 +965,13 @@
           <a:lstStyle/>
           <a:p>
             <a:r>
-              <a:t>PHOTO À METTRE (clic droit &gt; Changer l'image) : grand hall de musée avec un squelette de dinosaure et des visiteurs</a:t>
+              <a:t>Slide 7 — BENEFIT : prestige, visiteurs, image</a:t>
             </a:r>
           </a:p>
           <a:p/>
           <a:p>
             <a:r>
-              <a:t>Slide 7 — BENEFIT : prestige, visiteurs, image</a:t>
+              <a:t>Photo : Natural History Museum of Los Angeles County (Wikimedia Commons)</a:t>
             </a:r>
           </a:p>
         </p:txBody>
@@ -1041,13 +1041,13 @@
           <a:lstStyle/>
           <a:p>
             <a:r>
-              <a:t>PHOTO À METTRE (clic droit &gt; Changer l'image) : le squelette de Stan éclairé, ambiance salle de vente</a:t>
+              <a:t>Slide 8 — Prix et conclusion</a:t>
             </a:r>
           </a:p>
           <a:p/>
           <a:p>
             <a:r>
-              <a:t>Slide 8 — Prix et conclusion</a:t>
+              <a:t>Photo : Stan cast, New Mexico Museum of Natural History, Tkracinski, CC BY-SA 4.0 (Wikimedia Commons)</a:t>
             </a:r>
           </a:p>
         </p:txBody>
@@ -4063,7 +4063,7 @@
       <p:grpSpPr/>
       <p:pic>
         <p:nvPicPr>
-          <p:cNvPr id="2" name="Picture 1" descr="ph_full.png"/>
+          <p:cNvPr id="2" name="Picture 1" descr="s_full_1920.jpg"/>
           <p:cNvPicPr>
             <a:picLocks noChangeAspect="1"/>
           </p:cNvPicPr>
@@ -4226,7 +4226,7 @@
       <p:grpSpPr/>
       <p:pic>
         <p:nvPicPr>
-          <p:cNvPr id="2" name="Picture 1" descr="ph_half.png"/>
+          <p:cNvPr id="2" name="Picture 1" descr="s_skull2_960.jpg"/>
           <p:cNvPicPr>
             <a:picLocks noChangeAspect="1"/>
           </p:cNvPicPr>
@@ -4256,8 +4256,8 @@
         </p:nvSpPr>
         <p:spPr>
           <a:xfrm>
-            <a:off x="6696000" y="1900000"/>
-            <a:ext cx="4996000" cy="1400000"/>
+            <a:off x="6496000" y="1900000"/>
+            <a:ext cx="5696000" cy="1400000"/>
           </a:xfrm>
           <a:prstGeom prst="rect">
             <a:avLst/>
@@ -4272,7 +4272,7 @@
           <a:p>
             <a:pPr algn="l"/>
             <a:r>
-              <a:rPr sz="5400" b="1">
+              <a:rPr sz="4400" b="1">
                 <a:solidFill>
                   <a:srgbClr val="F4EFE6"/>
                 </a:solidFill>
@@ -4389,7 +4389,7 @@
       <p:grpSpPr/>
       <p:pic>
         <p:nvPicPr>
-          <p:cNvPr id="2" name="Picture 1" descr="ph_half.png"/>
+          <p:cNvPr id="2" name="Picture 1" descr="s_land_960.jpg"/>
           <p:cNvPicPr>
             <a:picLocks noChangeAspect="1"/>
           </p:cNvPicPr>
@@ -4622,7 +4622,7 @@
       <p:grpSpPr/>
       <p:pic>
         <p:nvPicPr>
-          <p:cNvPr id="2" name="Picture 1" descr="ph_half.png"/>
+          <p:cNvPr id="2" name="Picture 1" descr="s_scale_960.jpg"/>
           <p:cNvPicPr>
             <a:picLocks noChangeAspect="1"/>
           </p:cNvPicPr>
@@ -4820,7 +4820,7 @@
       <p:grpSpPr/>
       <p:pic>
         <p:nvPicPr>
-          <p:cNvPr id="2" name="Picture 1" descr="ph_half.png"/>
+          <p:cNvPr id="2" name="Picture 1" descr="s_dig_960.jpg"/>
           <p:cNvPicPr>
             <a:picLocks noChangeAspect="1"/>
           </p:cNvPicPr>
@@ -4983,7 +4983,7 @@
       <p:grpSpPr/>
       <p:pic>
         <p:nvPicPr>
-          <p:cNvPr id="2" name="Picture 1" descr="ph_half.png"/>
+          <p:cNvPr id="2" name="Picture 1" descr="s_skull_960.jpg"/>
           <p:cNvPicPr>
             <a:picLocks noChangeAspect="1"/>
           </p:cNvPicPr>
@@ -5146,7 +5146,7 @@
       <p:grpSpPr/>
       <p:pic>
         <p:nvPicPr>
-          <p:cNvPr id="2" name="Picture 1" descr="ph_half.png"/>
+          <p:cNvPr id="2" name="Picture 1" descr="s_hall_960.jpg"/>
           <p:cNvPicPr>
             <a:picLocks noChangeAspect="1"/>
           </p:cNvPicPr>
@@ -5309,7 +5309,7 @@
       <p:grpSpPr/>
       <p:pic>
         <p:nvPicPr>
-          <p:cNvPr id="2" name="Picture 1" descr="ph_full.png"/>
+          <p:cNvPr id="2" name="Picture 1" descr="s_mv_1920.jpg"/>
           <p:cNvPicPr>
             <a:picLocks noChangeAspect="1"/>
           </p:cNvPicPr>

</xml_diff>